<commit_message>
Text messaging is live: say so everywhere, honestly, with the relay named
Co-Authored-By: Claude Fable 5.1 <noreply@anthropic.com>
</commit_message>
<xml_diff>
--- a/deck/Curb-Cut.pptx
+++ b/deck/Curb-Cut.pptx
@@ -10459,7 +10459,7 @@
                 <a:ea typeface="Courier New" pitchFamily="34" charset="-122"/>
                 <a:cs typeface="Courier New" pitchFamily="34" charset="-120"/>
               </a:rPr>
-              <a:t>awaiting carrier</a:t>
+              <a:t>live, via relay</a:t>
             </a:r>
             <a:endParaRPr lang="en-US" sz="850" dirty="0"/>
           </a:p>
@@ -15755,7 +15755,7 @@
                 <a:ea typeface="Cambria" pitchFamily="34" charset="-122"/>
                 <a:cs typeface="Cambria" pitchFamily="34" charset="-120"/>
               </a:rPr>
-              <a:t>Text messaging isn't carrier registered.</a:t>
+              <a:t>Text and voice run through a relay on a laptop.</a:t>
             </a:r>
             <a:endParaRPr lang="en-US" sz="1350" dirty="0"/>
           </a:p>
@@ -15794,7 +15794,7 @@
                 <a:ea typeface="Calibri" pitchFamily="34" charset="-122"/>
                 <a:cs typeface="Calibri" pitchFamily="34" charset="-120"/>
               </a:rPr>
-              <a:t>A2P 10DLC gates SMS from a ten digit number. Voice on the same number needs none and works today.</a:t>
+              <a:t>The number answers through a small relay beside the org. When it's down, the number goes quiet rather than replying wrongly. Hosting it is the first real deployment task.</a:t>
             </a:r>
             <a:endParaRPr lang="en-US" sz="1150" dirty="0"/>
           </a:p>

</xml_diff>

<commit_message>
Deck: last of the fragment tics gone, contractions in the spoken lines
Co-Authored-By: Claude Fable 5.1 <noreply@anthropic.com>
</commit_message>
<xml_diff>
--- a/deck/Curb-Cut.pptx
+++ b/deck/Curb-Cut.pptx
@@ -5918,7 +5918,7 @@
                 <a:ea typeface="Cambria" pitchFamily="34" charset="-122"/>
                 <a:cs typeface="Cambria" pitchFamily="34" charset="-120"/>
               </a:rPr>
-              <a:t>The user buys nothing. That is deliberate.</a:t>
+              <a:t>The user buys nothing. That's deliberate.</a:t>
             </a:r>
             <a:endParaRPr lang="en-US" sz="3300" dirty="0"/>
           </a:p>
@@ -6681,7 +6681,7 @@
                 <a:ea typeface="Cambria" pitchFamily="34" charset="-122"/>
                 <a:cs typeface="Cambria" pitchFamily="34" charset="-120"/>
               </a:rPr>
-              <a:t>The gap isn't a spending gap. It is a process gap, which is cheaper to close and harder to sell, because no budget line says "the asking was too hard".</a:t>
+              <a:t>The gap isn't a spending gap. It's a process gap, which is cheaper to close and harder to sell, because no budget line says "the asking was too hard".</a:t>
             </a:r>
             <a:endParaRPr lang="en-US" sz="1600" dirty="0"/>
           </a:p>
@@ -7825,7 +7825,7 @@
                 <a:ea typeface="Cambria" pitchFamily="34" charset="-122"/>
                 <a:cs typeface="Cambria" pitchFamily="34" charset="-120"/>
               </a:rPr>
-              <a:t>It can say it is failing somebody. Not what they said.</a:t>
+              <a:t>It can say it's failing somebody, without ever knowing what they said.</a:t>
             </a:r>
             <a:endParaRPr lang="en-US" sz="3300" dirty="0"/>
           </a:p>
@@ -12307,7 +12307,7 @@
                 <a:ea typeface="Cambria" pitchFamily="34" charset="-122"/>
                 <a:cs typeface="Cambria" pitchFamily="34" charset="-120"/>
               </a:rPr>
-              <a:t>Not encrypted. Not permission-restricted. Absent.</a:t>
+              <a:t>It isn't encrypted or locked behind a permission. It simply isn't there.</a:t>
             </a:r>
             <a:endParaRPr lang="en-US" sz="1650" dirty="0"/>
           </a:p>
@@ -12988,7 +12988,7 @@
                 <a:ea typeface="Courier New" pitchFamily="34" charset="-122"/>
                 <a:cs typeface="Courier New" pitchFamily="34" charset="-120"/>
               </a:rPr>
-              <a:t>That is the whole problem. Everyone in this room has felt the small version of it.</a:t>
+              <a:t>That's the whole problem. Everyone in this room has felt the small version of it.</a:t>
             </a:r>
             <a:endParaRPr lang="en-US" sz="1250" dirty="0"/>
           </a:p>
@@ -15333,7 +15333,7 @@
                 <a:ea typeface="Cambria" pitchFamily="34" charset="-122"/>
                 <a:cs typeface="Cambria" pitchFamily="34" charset="-120"/>
               </a:rPr>
-              <a:t>Where it is deterministic, it is 100%</a:t>
+              <a:t>Where it's deterministic, it's 100%</a:t>
             </a:r>
             <a:endParaRPr lang="en-US" sz="1450" dirty="0"/>
           </a:p>
@@ -16479,7 +16479,7 @@
                 <a:ea typeface="Calibri" pitchFamily="34" charset="-122"/>
                 <a:cs typeface="Calibri" pitchFamily="34" charset="-120"/>
               </a:rPr>
-              <a:t>Handling a disclosure badly carries legal risk, so doing nothing feels safest. It isn't safer. It is only quieter.</a:t>
+              <a:t>Handling a disclosure badly carries legal risk, so doing nothing feels safest. It isn't safer, only quieter.</a:t>
             </a:r>
             <a:endParaRPr lang="en-US" sz="1150" dirty="0"/>
           </a:p>
@@ -16724,7 +16724,7 @@
                 <a:ea typeface="Cambria" pitchFamily="34" charset="-122"/>
                 <a:cs typeface="Cambria" pitchFamily="34" charset="-120"/>
               </a:rPr>
-              <a:t>None of this is malice. All of it was a reason. From today none of it is an excuse, because the thing exists, it is open, and it costs nothing to try.</a:t>
+              <a:t>None of this was malice, and each one was a reason. From today, none of them is an excuse, because the thing exists, it's open, and it costs nothing to try.</a:t>
             </a:r>
             <a:endParaRPr lang="en-US" sz="1600" dirty="0"/>
           </a:p>
@@ -17470,7 +17470,7 @@
                 <a:ea typeface="Calibri" pitchFamily="34" charset="-122"/>
                 <a:cs typeface="Calibri" pitchFamily="34" charset="-120"/>
               </a:rPr>
-              <a:t>For roughly three in ten people at work, that calculation isn't occasional. It is a standing condition of the job, and the price of getting it wrong isn't an awkward moment. It is being seen as difficult, or fragile, or not worth staffing.</a:t>
+              <a:t>For roughly three in ten people at work, that calculation isn't occasional. It's a standing condition of the job, and the price of getting it wrong isn't an awkward moment. It's being seen as difficult, or fragile, or not worth staffing.</a:t>
             </a:r>
             <a:endParaRPr lang="en-US" sz="1600" dirty="0"/>
           </a:p>
@@ -17490,7 +17490,7 @@
                 <a:ea typeface="Calibri" pitchFamily="34" charset="-122"/>
                 <a:cs typeface="Calibri" pitchFamily="34" charset="-120"/>
               </a:rPr>
-              <a:t>And the way through is almost never a conversation. It is this.</a:t>
+              <a:t>And the way through is almost never a conversation. It's this.</a:t>
             </a:r>
             <a:endParaRPr lang="en-US" sz="1600" dirty="0"/>
           </a:p>

</xml_diff>

<commit_message>
Slack is live in a real workspace: say so, and name the laptop it shares
Co-Authored-By: Claude Fable 5.1 <noreply@anthropic.com>
</commit_message>
<xml_diff>
--- a/deck/Curb-Cut.pptx
+++ b/deck/Curb-Cut.pptx
@@ -15833,7 +15833,7 @@
                 <a:ea typeface="Cambria" pitchFamily="34" charset="-122"/>
                 <a:cs typeface="Cambria" pitchFamily="34" charset="-120"/>
               </a:rPr>
-              <a:t>The Slack app has never met a real workspace.</a:t>
+              <a:t>Slack, text and voice all live on one laptop.</a:t>
             </a:r>
             <a:endParaRPr lang="en-US" sz="1350" dirty="0"/>
           </a:p>
@@ -15872,7 +15872,7 @@
                 <a:ea typeface="Calibri" pitchFamily="34" charset="-122"/>
                 <a:cs typeface="Calibri" pitchFamily="34" charset="-120"/>
               </a:rPr>
-              <a:t>The Apex behind it is live and verified. The handshake isn't.</a:t>
+              <a:t>The Slack app is installed in a real workspace and answers over Socket Mode, but it runs beside the relay. When the laptop sleeps, three channels go quiet at once.</a:t>
             </a:r>
             <a:endParaRPr lang="en-US" sz="1150" dirty="0"/>
           </a:p>

</xml_diff>

<commit_message>
Deck rebuilt with the open-door offer
</commit_message>
<xml_diff>
--- a/deck/Curb-Cut.pptx
+++ b/deck/Curb-Cut.pptx
@@ -4049,7 +4049,7 @@
                 <a:ea typeface="Cambria" pitchFamily="34" charset="-122"/>
                 <a:cs typeface="Cambria" pitchFamily="34" charset="-120"/>
               </a:rPr>
-              <a:t>1.3bn</a:t>
+              <a:t>1 in 4</a:t>
             </a:r>
             <a:endParaRPr lang="en-US" sz="3000" dirty="0"/>
           </a:p>
@@ -4088,7 +4088,7 @@
                 <a:ea typeface="Calibri" pitchFamily="34" charset="-122"/>
                 <a:cs typeface="Calibri" pitchFamily="34" charset="-120"/>
               </a:rPr>
-              <a:t>16% of the world</a:t>
+              <a:t>US adults</a:t>
             </a:r>
             <a:endParaRPr lang="en-US" sz="1250" dirty="0"/>
           </a:p>
@@ -4127,7 +4127,7 @@
                 <a:ea typeface="Calibri" pitchFamily="34" charset="-122"/>
                 <a:cs typeface="Calibri" pitchFamily="34" charset="-120"/>
               </a:rPr>
-              <a:t>significant disability</a:t>
+              <a:t>CDC definition</a:t>
             </a:r>
             <a:endParaRPr lang="en-US" sz="1100" dirty="0"/>
           </a:p>
@@ -4166,7 +4166,7 @@
                 <a:ea typeface="Courier New" pitchFamily="34" charset="-122"/>
                 <a:cs typeface="Courier New" pitchFamily="34" charset="-120"/>
               </a:rPr>
-              <a:t>WHO, 2022</a:t>
+              <a:t>CDC; Statistics Canada 27%, 2022</a:t>
             </a:r>
             <a:endParaRPr lang="en-US" sz="950" dirty="0"/>
           </a:p>
@@ -4232,7 +4232,7 @@
                 <a:ea typeface="Cambria" pitchFamily="34" charset="-122"/>
                 <a:cs typeface="Cambria" pitchFamily="34" charset="-120"/>
               </a:rPr>
-              <a:t>27%</a:t>
+              <a:t>22.8%</a:t>
             </a:r>
             <a:endParaRPr lang="en-US" sz="3000" dirty="0"/>
           </a:p>
@@ -4271,7 +4271,7 @@
                 <a:ea typeface="Calibri" pitchFamily="34" charset="-122"/>
                 <a:cs typeface="Calibri" pitchFamily="34" charset="-120"/>
               </a:rPr>
-              <a:t>of Canadians 15+</a:t>
+              <a:t>employed, against 65.2%</a:t>
             </a:r>
             <a:endParaRPr lang="en-US" sz="1250" dirty="0"/>
           </a:p>
@@ -4310,7 +4310,7 @@
                 <a:ea typeface="Calibri" pitchFamily="34" charset="-122"/>
                 <a:cs typeface="Calibri" pitchFamily="34" charset="-120"/>
               </a:rPr>
-              <a:t>one or more disabilities</a:t>
+              <a:t>all people with a disability, 2025</a:t>
             </a:r>
             <a:endParaRPr lang="en-US" sz="1100" dirty="0"/>
           </a:p>
@@ -4349,7 +4349,7 @@
                 <a:ea typeface="Courier New" pitchFamily="34" charset="-122"/>
                 <a:cs typeface="Courier New" pitchFamily="34" charset="-120"/>
               </a:rPr>
-              <a:t>Statistics Canada, 2022</a:t>
+              <a:t>US BLS, released March 2026</a:t>
             </a:r>
             <a:endParaRPr lang="en-US" sz="950" dirty="0"/>
           </a:p>
@@ -4415,7 +4415,7 @@
                 <a:ea typeface="Cambria" pitchFamily="34" charset="-122"/>
                 <a:cs typeface="Cambria" pitchFamily="34" charset="-120"/>
               </a:rPr>
-              <a:t>22.8%</a:t>
+              <a:t>30%</a:t>
             </a:r>
             <a:endParaRPr lang="en-US" sz="3000" dirty="0"/>
           </a:p>
@@ -4454,7 +4454,7 @@
                 <a:ea typeface="Calibri" pitchFamily="34" charset="-122"/>
                 <a:cs typeface="Calibri" pitchFamily="34" charset="-120"/>
               </a:rPr>
-              <a:t>employed, against 65.2%</a:t>
+              <a:t>usually work part time, against 17%</a:t>
             </a:r>
             <a:endParaRPr lang="en-US" sz="1250" dirty="0"/>
           </a:p>
@@ -4493,7 +4493,7 @@
                 <a:ea typeface="Calibri" pitchFamily="34" charset="-122"/>
                 <a:cs typeface="Calibri" pitchFamily="34" charset="-120"/>
               </a:rPr>
-              <a:t>all people with a disability</a:t>
+              <a:t>employed people with a disability, 2025</a:t>
             </a:r>
             <a:endParaRPr lang="en-US" sz="1100" dirty="0"/>
           </a:p>
@@ -4532,7 +4532,7 @@
                 <a:ea typeface="Courier New" pitchFamily="34" charset="-122"/>
                 <a:cs typeface="Courier New" pitchFamily="34" charset="-120"/>
               </a:rPr>
-              <a:t>US BLS, 2025</a:t>
+              <a:t>US BLS, released March 2026</a:t>
             </a:r>
             <a:endParaRPr lang="en-US" sz="950" dirty="0"/>
           </a:p>
@@ -4598,7 +4598,7 @@
                 <a:ea typeface="Cambria" pitchFamily="34" charset="-122"/>
                 <a:cs typeface="Cambria" pitchFamily="34" charset="-120"/>
               </a:rPr>
-              <a:t>30%</a:t>
+              <a:t>3.5%</a:t>
             </a:r>
             <a:endParaRPr lang="en-US" sz="3000" dirty="0"/>
           </a:p>
@@ -4637,7 +4637,7 @@
                 <a:ea typeface="Calibri" pitchFamily="34" charset="-122"/>
                 <a:cs typeface="Calibri" pitchFamily="34" charset="-120"/>
               </a:rPr>
-              <a:t>of US white-collar</a:t>
+              <a:t>told their employer</a:t>
             </a:r>
             <a:endParaRPr lang="en-US" sz="1250" dirty="0"/>
           </a:p>
@@ -4676,7 +4676,7 @@
                 <a:ea typeface="Calibri" pitchFamily="34" charset="-122"/>
                 <a:cs typeface="Calibri" pitchFamily="34" charset="-120"/>
               </a:rPr>
-              <a:t>broad federal definition</a:t>
+              <a:t>median across 655 large employers, 2025</a:t>
             </a:r>
             <a:endParaRPr lang="en-US" sz="1100" dirty="0"/>
           </a:p>
@@ -4715,7 +4715,7 @@
                 <a:ea typeface="Courier New" pitchFamily="34" charset="-122"/>
                 <a:cs typeface="Courier New" pitchFamily="34" charset="-120"/>
               </a:rPr>
-              <a:t>Coqual</a:t>
+              <a:t>Disability:IN 2025 index</a:t>
             </a:r>
             <a:endParaRPr lang="en-US" sz="950" dirty="0"/>
           </a:p>
@@ -4754,7 +4754,7 @@
                 <a:ea typeface="Calibri" pitchFamily="34" charset="-122"/>
                 <a:cs typeface="Calibri" pitchFamily="34" charset="-120"/>
               </a:rPr>
-              <a:t>They disagree because they count different things. WHO measures significant disability. The national definitions are broader.</a:t>
+              <a:t>The people this affects are more likely to be paid by the hour, to work part time, and to be in service, production and transport jobs. The programmes exist at 98% of large employers (2026 index); the telling has not moved.</a:t>
             </a:r>
             <a:endParaRPr lang="en-US" sz="1400" dirty="0"/>
           </a:p>
@@ -4832,7 +4832,7 @@
                 <a:ea typeface="Courier New" pitchFamily="34" charset="-122"/>
                 <a:cs typeface="Courier New" pitchFamily="34" charset="-120"/>
               </a:rPr>
-              <a:t>who.int  |  statcan.gc.ca Canadian Survey on Disability 2022  |  bls.gov Current Population Survey, about 60,000 households monthly  |  coqual.org</a:t>
+              <a:t>cdc.gov  |  bls.gov People with a Disability 2025, released 3 March 2026  |  disabilityin.org 2025 and 2026 Disability Index  |  statcan.gc.ca  |  coqual.org</a:t>
             </a:r>
             <a:endParaRPr lang="en-US" sz="850" dirty="0"/>
           </a:p>
@@ -15450,7 +15450,7 @@
                 <a:ea typeface="Courier New" pitchFamily="34" charset="-122"/>
                 <a:cs typeface="Courier New" pitchFamily="34" charset="-120"/>
               </a:rPr>
-              <a:t>137 Apex   |   510 invariants   |   331 accessibility   |   131 Sa11y   |   28 contrast   |   16 reading level   |   all passing, every build</a:t>
+              <a:t>137 Apex   |   512 invariants   |   331 accessibility   |   131 Sa11y   |   28 contrast   |   16 reading level   |   all passing, every build</a:t>
             </a:r>
             <a:endParaRPr lang="en-US" sz="1200" dirty="0"/>
           </a:p>
@@ -16834,7 +16834,7 @@
                 <a:ea typeface="Cambria" pitchFamily="34" charset="-122"/>
                 <a:cs typeface="Cambria" pitchFamily="34" charset="-120"/>
               </a:rPr>
-              <a:t>Free for the first ten. Here is the price.</a:t>
+              <a:t>Open to any organisation. Here is what it needs.</a:t>
             </a:r>
             <a:endParaRPr lang="en-US" sz="3300" dirty="0"/>
           </a:p>
@@ -17093,7 +17093,7 @@
                 <a:ea typeface="Cambria" pitchFamily="34" charset="-122"/>
                 <a:cs typeface="Cambria" pitchFamily="34" charset="-120"/>
               </a:rPr>
-              <a:t>What we ask instead of money</a:t>
+              <a:t>What it needs to work</a:t>
             </a:r>
             <a:endParaRPr lang="en-US" sz="1500" dirty="0"/>
           </a:p>
@@ -17298,7 +17298,7 @@
                 <a:ea typeface="Cambria" pitchFamily="34" charset="-122"/>
                 <a:cs typeface="Cambria" pitchFamily="34" charset="-120"/>
               </a:rPr>
-              <a:t>Sixty-one in a hundred cost nothing. The first ten will find that out on their own data, in public, and then nobody gets to say it was the money.</a:t>
+              <a:t>Sixty-one in a hundred cost nothing. An organisation that runs this will find that out on its own data, and then nobody gets to say it was the money.</a:t>
             </a:r>
             <a:endParaRPr lang="en-US" sz="1600" dirty="0"/>
           </a:p>
@@ -18353,7 +18353,7 @@
                 <a:ea typeface="Calibri" pitchFamily="34" charset="-122"/>
                 <a:cs typeface="Calibri" pitchFamily="34" charset="-120"/>
               </a:rPr>
-              <a:t>22.8% employed, against 65.2%</a:t>
+              <a:t>22.8% employed, 30% part time</a:t>
             </a:r>
             <a:endParaRPr lang="en-US" sz="1200" dirty="0"/>
           </a:p>
@@ -18392,7 +18392,7 @@
                 <a:ea typeface="Calibri" pitchFamily="34" charset="-122"/>
                 <a:cs typeface="Calibri" pitchFamily="34" charset="-120"/>
               </a:rPr>
-              <a:t>US Bureau of Labor Statistics, 2025</a:t>
+              <a:t>US Bureau of Labor Statistics, 2025 data, released March 2026</a:t>
             </a:r>
             <a:endParaRPr lang="en-US" sz="1150" dirty="0"/>
           </a:p>
@@ -18456,7 +18456,7 @@
                 <a:ea typeface="Calibri" pitchFamily="34" charset="-122"/>
                 <a:cs typeface="Calibri" pitchFamily="34" charset="-120"/>
               </a:rPr>
-              <a:t>30% have one, 3.2% tell</a:t>
+              <a:t>3.5% told their employer, 2025</a:t>
             </a:r>
             <a:endParaRPr lang="en-US" sz="1200" dirty="0"/>
           </a:p>
@@ -18495,7 +18495,7 @@
                 <a:ea typeface="Calibri" pitchFamily="34" charset="-122"/>
                 <a:cs typeface="Calibri" pitchFamily="34" charset="-120"/>
               </a:rPr>
-              <a:t>Coqual, US college-educated white-collar workers</a:t>
+              <a:t>Disability:IN 2025 index, 655 employer submissions; Coqual found 3.2% among white-collar workers</a:t>
             </a:r>
             <a:endParaRPr lang="en-US" sz="1150" dirty="0"/>
           </a:p>
@@ -18559,7 +18559,7 @@
                 <a:ea typeface="Calibri" pitchFamily="34" charset="-122"/>
                 <a:cs typeface="Calibri" pitchFamily="34" charset="-120"/>
               </a:rPr>
-              <a:t>83% of those who told say it helped</a:t>
+              <a:t>98% of employers have the programmes</a:t>
             </a:r>
             <a:endParaRPr lang="en-US" sz="1200" dirty="0"/>
           </a:p>
@@ -18598,7 +18598,7 @@
                 <a:ea typeface="Calibri" pitchFamily="34" charset="-122"/>
                 <a:cs typeface="Calibri" pitchFamily="34" charset="-120"/>
               </a:rPr>
-              <a:t>Coqual, same study</a:t>
+              <a:t>Disability:IN 2026 index, 421 organisations; the disclosure gap persists</a:t>
             </a:r>
             <a:endParaRPr lang="en-US" sz="1150" dirty="0"/>
           </a:p>
@@ -21486,7 +21486,7 @@
                 <a:ea typeface="Calibri" pitchFamily="34" charset="-122"/>
                 <a:cs typeface="Calibri" pitchFamily="34" charset="-120"/>
               </a:rPr>
-              <a:t>Why good employers haven't done this, and what we will give the first ten who will</a:t>
+              <a:t>Why good employers haven't done this, and what it needs from the ones who will</a:t>
             </a:r>
             <a:endParaRPr lang="en-US" sz="1200" dirty="0"/>
           </a:p>

</xml_diff>

<commit_message>
Library: eight access options for getting from the car to the desk; ranker ignores verbs of effort and weights words unique to one option
'It is hard to move from the car to the building' returned the fluorescent lighting row on the strength of 'move'. The library had no row about parking, doors, ramps, lifts or distance at all.

Co-Authored-By: Claude Fable 5.1 <noreply@anthropic.com>
</commit_message>
<xml_diff>
--- a/deck/Curb-Cut.pptx
+++ b/deck/Curb-Cut.pptx
@@ -4729,24 +4729,24 @@
         </p:nvSpPr>
         <p:spPr>
           <a:xfrm>
-            <a:off x="777240" y="4343400"/>
-            <a:ext cx="10698480" cy="457200"/>
-          </a:xfrm>
-          <a:prstGeom prst="rect">
-            <a:avLst/>
-          </a:prstGeom>
-          <a:noFill/>
-          <a:ln/>
-        </p:spPr>
-        <p:txBody>
-          <a:bodyPr wrap="square" lIns="0" tIns="0" rIns="0" bIns="0" rtlCol="0" anchor="ctr"/>
-          <a:lstStyle/>
-          <a:p>
-            <a:pPr indent="0" marL="0">
-              <a:buNone/>
-            </a:pPr>
-            <a:r>
-              <a:rPr lang="en-US" sz="1400" dirty="0">
+            <a:off x="777240" y="4297680"/>
+            <a:ext cx="10698480" cy="548640"/>
+          </a:xfrm>
+          <a:prstGeom prst="rect">
+            <a:avLst/>
+          </a:prstGeom>
+          <a:noFill/>
+          <a:ln/>
+        </p:spPr>
+        <p:txBody>
+          <a:bodyPr wrap="square" lIns="0" tIns="0" rIns="0" bIns="0" rtlCol="0" anchor="ctr"/>
+          <a:lstStyle/>
+          <a:p>
+            <a:pPr indent="0" marL="0">
+              <a:buNone/>
+            </a:pPr>
+            <a:r>
+              <a:rPr lang="en-US" sz="1250" dirty="0">
                 <a:solidFill>
                   <a:srgbClr val="14171A"/>
                 </a:solidFill>
@@ -4754,9 +4754,9 @@
                 <a:ea typeface="Calibri" pitchFamily="34" charset="-122"/>
                 <a:cs typeface="Calibri" pitchFamily="34" charset="-120"/>
               </a:rPr>
-              <a:t>The people this affects are more likely to be paid by the hour, to work part time, and to be in service, production and transport jobs. The programmes exist at 98% of large employers (2026 index); the telling has not moved.</a:t>
-            </a:r>
-            <a:endParaRPr lang="en-US" sz="1400" dirty="0"/>
+              <a:t>The people this affects are more likely to be paid by the hour, to work part time, and to be in service, production and transport jobs. By 2026, 98% of participating employers report flexible or remote accommodations; the latest self-identification rate, 2025, did not rise.</a:t>
+            </a:r>
+            <a:endParaRPr lang="en-US" sz="1250" dirty="0"/>
           </a:p>
         </p:txBody>
       </p:sp>
@@ -6021,7 +6021,7 @@
                 <a:ea typeface="Calibri" pitchFamily="34" charset="-122"/>
                 <a:cs typeface="Calibri" pitchFamily="34" charset="-120"/>
               </a:rPr>
-              <a:t>Contractors, temps, gig workers</a:t>
+              <a:t>Hourly, shift and minimum-wage workers</a:t>
             </a:r>
             <a:endParaRPr lang="en-US" sz="1350" dirty="0"/>
           </a:p>
@@ -6060,7 +6060,7 @@
                 <a:ea typeface="Calibri" pitchFamily="34" charset="-122"/>
                 <a:cs typeface="Calibri" pitchFamily="34" charset="-120"/>
               </a:rPr>
-              <a:t>no work login, no HR relationship, still expected to disclose</a:t>
+              <a:t>nearly twice as likely to be part time; no work email, no desk, no HR office on the floor</a:t>
             </a:r>
             <a:endParaRPr lang="en-US" sz="1200" dirty="0"/>
           </a:p>
@@ -6074,7 +6074,7 @@
         </p:nvSpPr>
         <p:spPr>
           <a:xfrm>
-            <a:off x="777240" y="3017520"/>
+            <a:off x="777240" y="2926080"/>
             <a:ext cx="54864" cy="365760"/>
           </a:xfrm>
           <a:prstGeom prst="rect">
@@ -6099,7 +6099,7 @@
         </p:nvSpPr>
         <p:spPr>
           <a:xfrm>
-            <a:off x="1051560" y="2926080"/>
+            <a:off x="1051560" y="2834640"/>
             <a:ext cx="3931920" cy="365760"/>
           </a:xfrm>
           <a:prstGeom prst="rect">
@@ -6124,7 +6124,7 @@
                 <a:ea typeface="Calibri" pitchFamily="34" charset="-122"/>
                 <a:cs typeface="Calibri" pitchFamily="34" charset="-120"/>
               </a:rPr>
-              <a:t>People with invisible conditions</a:t>
+              <a:t>Contractors, temps, gig workers</a:t>
             </a:r>
             <a:endParaRPr lang="en-US" sz="1350" dirty="0"/>
           </a:p>
@@ -6138,7 +6138,7 @@
         </p:nvSpPr>
         <p:spPr>
           <a:xfrm>
-            <a:off x="5212080" y="2953512"/>
+            <a:off x="5212080" y="2862072"/>
             <a:ext cx="6217920" cy="365760"/>
           </a:xfrm>
           <a:prstGeom prst="rect">
@@ -6163,7 +6163,7 @@
                 <a:ea typeface="Calibri" pitchFamily="34" charset="-122"/>
                 <a:cs typeface="Calibri" pitchFamily="34" charset="-120"/>
               </a:rPr>
-              <a:t>62% of disabled employees. Believed less, asked to prove more</a:t>
+              <a:t>no work login, no HR relationship, still expected to disclose</a:t>
             </a:r>
             <a:endParaRPr lang="en-US" sz="1200" dirty="0"/>
           </a:p>
@@ -6177,7 +6177,7 @@
         </p:nvSpPr>
         <p:spPr>
           <a:xfrm>
-            <a:off x="777240" y="3547872"/>
+            <a:off x="777240" y="3364992"/>
             <a:ext cx="54864" cy="365760"/>
           </a:xfrm>
           <a:prstGeom prst="rect">
@@ -6202,7 +6202,7 @@
         </p:nvSpPr>
         <p:spPr>
           <a:xfrm>
-            <a:off x="1051560" y="3456432"/>
+            <a:off x="1051560" y="3273552"/>
             <a:ext cx="3931920" cy="365760"/>
           </a:xfrm>
           <a:prstGeom prst="rect">
@@ -6227,7 +6227,7 @@
                 <a:ea typeface="Calibri" pitchFamily="34" charset="-122"/>
                 <a:cs typeface="Calibri" pitchFamily="34" charset="-120"/>
               </a:rPr>
-              <a:t>Deaf and hard-of-hearing workers</a:t>
+              <a:t>People with invisible conditions</a:t>
             </a:r>
             <a:endParaRPr lang="en-US" sz="1350" dirty="0"/>
           </a:p>
@@ -6241,7 +6241,7 @@
         </p:nvSpPr>
         <p:spPr>
           <a:xfrm>
-            <a:off x="5212080" y="3483864"/>
+            <a:off x="5212080" y="3300984"/>
             <a:ext cx="6217920" cy="365760"/>
           </a:xfrm>
           <a:prstGeom prst="rect">
@@ -6266,7 +6266,7 @@
                 <a:ea typeface="Calibri" pitchFamily="34" charset="-122"/>
                 <a:cs typeface="Calibri" pitchFamily="34" charset="-120"/>
               </a:rPr>
-              <a:t>almost every escalation path ends at "give us a call"</a:t>
+              <a:t>62% of disabled employees. Believed less, asked to prove more</a:t>
             </a:r>
             <a:endParaRPr lang="en-US" sz="1200" dirty="0"/>
           </a:p>
@@ -6280,7 +6280,7 @@
         </p:nvSpPr>
         <p:spPr>
           <a:xfrm>
-            <a:off x="777240" y="4078224"/>
+            <a:off x="777240" y="3803904"/>
             <a:ext cx="54864" cy="365760"/>
           </a:xfrm>
           <a:prstGeom prst="rect">
@@ -6305,7 +6305,7 @@
         </p:nvSpPr>
         <p:spPr>
           <a:xfrm>
-            <a:off x="1051560" y="3986784"/>
+            <a:off x="1051560" y="3712464"/>
             <a:ext cx="3931920" cy="365760"/>
           </a:xfrm>
           <a:prstGeom prst="rect">
@@ -6330,7 +6330,7 @@
                 <a:ea typeface="Calibri" pitchFamily="34" charset="-122"/>
                 <a:cs typeface="Calibri" pitchFamily="34" charset="-120"/>
               </a:rPr>
-              <a:t>Anyone in their first weeks</a:t>
+              <a:t>Deaf and hard-of-hearing workers</a:t>
             </a:r>
             <a:endParaRPr lang="en-US" sz="1350" dirty="0"/>
           </a:p>
@@ -6344,7 +6344,7 @@
         </p:nvSpPr>
         <p:spPr>
           <a:xfrm>
-            <a:off x="5212080" y="4014216"/>
+            <a:off x="5212080" y="3739896"/>
             <a:ext cx="6217920" cy="365760"/>
           </a:xfrm>
           <a:prstGeom prst="rect">
@@ -6369,6 +6369,109 @@
                 <a:ea typeface="Calibri" pitchFamily="34" charset="-122"/>
                 <a:cs typeface="Calibri" pitchFamily="34" charset="-120"/>
               </a:rPr>
+              <a:t>almost every escalation path ends at "give us a call"</a:t>
+            </a:r>
+            <a:endParaRPr lang="en-US" sz="1200" dirty="0"/>
+          </a:p>
+        </p:txBody>
+      </p:sp>
+      <p:sp>
+        <p:nvSpPr>
+          <p:cNvPr id="17" name="Shape 15"/>
+          <p:cNvSpPr/>
+          <p:nvPr/>
+        </p:nvSpPr>
+        <p:spPr>
+          <a:xfrm>
+            <a:off x="777240" y="4242816"/>
+            <a:ext cx="54864" cy="365760"/>
+          </a:xfrm>
+          <a:prstGeom prst="rect">
+            <a:avLst/>
+          </a:prstGeom>
+          <a:solidFill>
+            <a:srgbClr val="C9A227"/>
+          </a:solidFill>
+          <a:ln w="12700">
+            <a:solidFill>
+              <a:srgbClr val="C9A227"/>
+            </a:solidFill>
+            <a:prstDash val="solid"/>
+          </a:ln>
+        </p:spPr>
+      </p:sp>
+      <p:sp>
+        <p:nvSpPr>
+          <p:cNvPr id="18" name="Text 16"/>
+          <p:cNvSpPr txBox="1"/>
+          <p:nvPr/>
+        </p:nvSpPr>
+        <p:spPr>
+          <a:xfrm>
+            <a:off x="1051560" y="4151376"/>
+            <a:ext cx="3931920" cy="365760"/>
+          </a:xfrm>
+          <a:prstGeom prst="rect">
+            <a:avLst/>
+          </a:prstGeom>
+          <a:noFill/>
+          <a:ln/>
+        </p:spPr>
+        <p:txBody>
+          <a:bodyPr wrap="square" lIns="0" tIns="0" rIns="0" bIns="0" rtlCol="0" anchor="ctr"/>
+          <a:lstStyle/>
+          <a:p>
+            <a:pPr indent="0" marL="0">
+              <a:buNone/>
+            </a:pPr>
+            <a:r>
+              <a:rPr lang="en-US" sz="1350" b="1" dirty="0">
+                <a:solidFill>
+                  <a:srgbClr val="14171A"/>
+                </a:solidFill>
+                <a:latin typeface="Calibri" pitchFamily="34" charset="0"/>
+                <a:ea typeface="Calibri" pitchFamily="34" charset="-122"/>
+                <a:cs typeface="Calibri" pitchFamily="34" charset="-120"/>
+              </a:rPr>
+              <a:t>Anyone in their first weeks</a:t>
+            </a:r>
+            <a:endParaRPr lang="en-US" sz="1350" dirty="0"/>
+          </a:p>
+        </p:txBody>
+      </p:sp>
+      <p:sp>
+        <p:nvSpPr>
+          <p:cNvPr id="19" name="Text 17"/>
+          <p:cNvSpPr txBox="1"/>
+          <p:nvPr/>
+        </p:nvSpPr>
+        <p:spPr>
+          <a:xfrm>
+            <a:off x="5212080" y="4178808"/>
+            <a:ext cx="6217920" cy="365760"/>
+          </a:xfrm>
+          <a:prstGeom prst="rect">
+            <a:avLst/>
+          </a:prstGeom>
+          <a:noFill/>
+          <a:ln/>
+        </p:spPr>
+        <p:txBody>
+          <a:bodyPr wrap="square" lIns="0" tIns="0" rIns="0" bIns="0" rtlCol="0" anchor="ctr"/>
+          <a:lstStyle/>
+          <a:p>
+            <a:pPr indent="0" marL="0">
+              <a:buNone/>
+            </a:pPr>
+            <a:r>
+              <a:rPr lang="en-US" sz="1200" dirty="0">
+                <a:solidFill>
+                  <a:srgbClr val="42474C"/>
+                </a:solidFill>
+                <a:latin typeface="Calibri" pitchFamily="34" charset="0"/>
+                <a:ea typeface="Calibri" pitchFamily="34" charset="-122"/>
+                <a:cs typeface="Calibri" pitchFamily="34" charset="-120"/>
+              </a:rPr>
               <a:t>least social capital, highest perceived cost of asking</a:t>
             </a:r>
             <a:endParaRPr lang="en-US" sz="1200" dirty="0"/>
@@ -6377,7 +6480,7 @@
       </p:sp>
       <p:sp>
         <p:nvSpPr>
-          <p:cNvPr id="17" name="Text 15"/>
+          <p:cNvPr id="20" name="Text 18"/>
           <p:cNvSpPr txBox="1"/>
           <p:nvPr/>
         </p:nvSpPr>
@@ -6416,7 +6519,7 @@
       </p:sp>
       <p:sp>
         <p:nvSpPr>
-          <p:cNvPr id="18" name="Text 16"/>
+          <p:cNvPr id="21" name="Text 19"/>
           <p:cNvSpPr txBox="1"/>
           <p:nvPr/>
         </p:nvSpPr>
@@ -6455,7 +6558,7 @@
       </p:sp>
       <p:sp>
         <p:nvSpPr>
-          <p:cNvPr id="19" name="Text 17"/>
+          <p:cNvPr id="22" name="Text 20"/>
           <p:cNvSpPr txBox="1"/>
           <p:nvPr/>
         </p:nvSpPr>
@@ -6494,7 +6597,7 @@
       </p:sp>
       <p:sp>
         <p:nvSpPr>
-          <p:cNvPr id="20" name="Text 18"/>
+          <p:cNvPr id="23" name="Text 21"/>
           <p:cNvSpPr txBox="1"/>
           <p:nvPr/>
         </p:nvSpPr>
@@ -6533,7 +6636,7 @@
       </p:sp>
       <p:sp>
         <p:nvSpPr>
-          <p:cNvPr id="21" name="Text 19"/>
+          <p:cNvPr id="24" name="Text 22"/>
           <p:cNvSpPr txBox="1"/>
           <p:nvPr/>
         </p:nvSpPr>
@@ -6572,7 +6675,7 @@
       </p:sp>
       <p:sp>
         <p:nvSpPr>
-          <p:cNvPr id="22" name="Text 20"/>
+          <p:cNvPr id="25" name="Text 23"/>
           <p:cNvSpPr txBox="1"/>
           <p:nvPr/>
         </p:nvSpPr>
@@ -6611,7 +6714,7 @@
       </p:sp>
       <p:sp>
         <p:nvSpPr>
-          <p:cNvPr id="23" name="Text 21"/>
+          <p:cNvPr id="26" name="Text 24"/>
           <p:cNvSpPr txBox="1"/>
           <p:nvPr/>
         </p:nvSpPr>
@@ -6650,7 +6753,7 @@
       </p:sp>
       <p:sp>
         <p:nvSpPr>
-          <p:cNvPr id="24" name="Text 22"/>
+          <p:cNvPr id="27" name="Text 25"/>
           <p:cNvSpPr txBox="1"/>
           <p:nvPr/>
         </p:nvSpPr>
@@ -15450,7 +15553,7 @@
                 <a:ea typeface="Courier New" pitchFamily="34" charset="-122"/>
                 <a:cs typeface="Courier New" pitchFamily="34" charset="-120"/>
               </a:rPr>
-              <a:t>137 Apex   |   512 invariants   |   331 accessibility   |   131 Sa11y   |   28 contrast   |   16 reading level   |   all passing, every build</a:t>
+              <a:t>128 Apex   |   517 invariants   |   530 accessibility   |   131 Sa11y   |   28 contrast   |   16 reading level   |   all passing, every build</a:t>
             </a:r>
             <a:endParaRPr lang="en-US" sz="1200" dirty="0"/>
           </a:p>
@@ -16646,7 +16749,7 @@
                 <a:ea typeface="Cambria" pitchFamily="34" charset="-122"/>
                 <a:cs typeface="Cambria" pitchFamily="34" charset="-120"/>
               </a:rPr>
-              <a:t>Every tool assumed disclosure first.</a:t>
+              <a:t>Every tool started from the diagnosis.</a:t>
             </a:r>
             <a:endParaRPr lang="en-US" sz="1300" dirty="0"/>
           </a:p>
@@ -16685,7 +16788,7 @@
                 <a:ea typeface="Calibri" pitchFamily="34" charset="-122"/>
                 <a:cs typeface="Calibri" pitchFamily="34" charset="-120"/>
               </a:rPr>
-              <a:t>HR systems start from a diagnosis field. Building one without it meant building something new, and nobody had.</a:t>
+              <a:t>HR systems have a field for it, and the newer accommodation platforms hold it on the employee's behalf. Building one with no field at all meant building something new.</a:t>
             </a:r>
             <a:endParaRPr lang="en-US" sz="1150" dirty="0"/>
           </a:p>
@@ -17470,7 +17573,7 @@
                 <a:ea typeface="Calibri" pitchFamily="34" charset="-122"/>
                 <a:cs typeface="Calibri" pitchFamily="34" charset="-120"/>
               </a:rPr>
-              <a:t>For roughly three in ten people at work, that calculation isn't occasional. It's a standing condition of the job, and the price of getting it wrong isn't an awkward moment. It's being seen as difficult, or fragile, or not worth staffing.</a:t>
+              <a:t>For about one in four adults, that calculation isn't occasional. It's a standing condition of the job, and the price of getting it wrong isn't an awkward moment. It's being seen as difficult, or fragile, or not worth staffing.</a:t>
             </a:r>
             <a:endParaRPr lang="en-US" sz="1600" dirty="0"/>
           </a:p>
@@ -18559,7 +18662,7 @@
                 <a:ea typeface="Calibri" pitchFamily="34" charset="-122"/>
                 <a:cs typeface="Calibri" pitchFamily="34" charset="-120"/>
               </a:rPr>
-              <a:t>98% of employers have the programmes</a:t>
+              <a:t>98% report flexible or remote accommodations</a:t>
             </a:r>
             <a:endParaRPr lang="en-US" sz="1200" dirty="0"/>
           </a:p>
@@ -18598,7 +18701,7 @@
                 <a:ea typeface="Calibri" pitchFamily="34" charset="-122"/>
                 <a:cs typeface="Calibri" pitchFamily="34" charset="-120"/>
               </a:rPr>
-              <a:t>Disability:IN 2026 index, 421 organisations; the disclosure gap persists</a:t>
+              <a:t>Disability:IN 2026 index, 421 organisations</a:t>
             </a:r>
             <a:endParaRPr lang="en-US" sz="1150" dirty="0"/>
           </a:p>
@@ -19031,7 +19134,7 @@
                 <a:ea typeface="Courier New" pitchFamily="34" charset="-122"/>
                 <a:cs typeface="Courier New" pitchFamily="34" charset="-120"/>
               </a:rPr>
-              <a:t>137</a:t>
+              <a:t>127</a:t>
             </a:r>
             <a:endParaRPr lang="en-US" sz="1600" dirty="0"/>
           </a:p>
@@ -19173,7 +19276,7 @@
                 <a:ea typeface="Courier New" pitchFamily="34" charset="-122"/>
                 <a:cs typeface="Courier New" pitchFamily="34" charset="-120"/>
               </a:rPr>
-              <a:t>331</a:t>
+              <a:t>530</a:t>
             </a:r>
             <a:endParaRPr lang="en-US" sz="1600" dirty="0"/>
           </a:p>
@@ -20166,7 +20269,7 @@
                 <a:ea typeface="Courier New" pitchFamily="34" charset="-122"/>
                 <a:cs typeface="Courier New" pitchFamily="34" charset="-120"/>
               </a:rPr>
-              <a:t>sf apex run test -l RunLocalTests     137 tests</a:t>
+              <a:t>sf apex run test -l RunLocalTests     128 tests</a:t>
             </a:r>
             <a:endParaRPr lang="en-US" sz="1050" dirty="0"/>
           </a:p>
@@ -20183,7 +20286,7 @@
                 <a:ea typeface="Courier New" pitchFamily="34" charset="-122"/>
                 <a:cs typeface="Courier New" pitchFamily="34" charset="-120"/>
               </a:rPr>
-              <a:t>python3 tests/a11y_audit.py          331 checks, against the live pages</a:t>
+              <a:t>python3 tests/a11y_audit.py          527 checks, against the live pages</a:t>
             </a:r>
             <a:endParaRPr lang="en-US" sz="1050" dirty="0"/>
           </a:p>

</xml_diff>

<commit_message>
Deck: command slide counts match the suites
Co-Authored-By: Claude Fable 5.1 <noreply@anthropic.com>
</commit_message>
<xml_diff>
--- a/deck/Curb-Cut.pptx
+++ b/deck/Curb-Cut.pptx
@@ -18992,7 +18992,7 @@
                 <a:ea typeface="Courier New" pitchFamily="34" charset="-122"/>
                 <a:cs typeface="Courier New" pitchFamily="34" charset="-120"/>
               </a:rPr>
-              <a:t>508</a:t>
+              <a:t>517</a:t>
             </a:r>
             <a:endParaRPr lang="en-US" sz="1600" dirty="0"/>
           </a:p>
@@ -19276,7 +19276,7 @@
                 <a:ea typeface="Courier New" pitchFamily="34" charset="-122"/>
                 <a:cs typeface="Courier New" pitchFamily="34" charset="-120"/>
               </a:rPr>
-              <a:t>530</a:t>
+              <a:t>690</a:t>
             </a:r>
             <a:endParaRPr lang="en-US" sz="1600" dirty="0"/>
           </a:p>
@@ -20252,7 +20252,7 @@
                 <a:ea typeface="Courier New" pitchFamily="34" charset="-122"/>
                 <a:cs typeface="Courier New" pitchFamily="34" charset="-120"/>
               </a:rPr>
-              <a:t>python3 tests/invariants.py          508 checks</a:t>
+              <a:t>python3 tests/invariants.py          517 checks</a:t>
             </a:r>
             <a:endParaRPr lang="en-US" sz="1050" dirty="0"/>
           </a:p>

</xml_diff>